<commit_message>
docs(trimestre4): reorganizar y completar objetivo general
Se reorganiza la presentación de entregables del cuarto trimestre y se completa el objetivo general con el punto que faltaba.
</commit_message>
<xml_diff>
--- a/Cuarto Trimestre/Presentación - 4 Trimestre.pptx
+++ b/Cuarto Trimestre/Presentación - 4 Trimestre.pptx
@@ -5,7 +5,7 @@
     <p:sldMasterId id="2147483648" r:id="rId1"/>
   </p:sldMasterIdLst>
   <p:notesMasterIdLst>
-    <p:notesMasterId r:id="rId12"/>
+    <p:notesMasterId r:id="rId13"/>
   </p:notesMasterIdLst>
   <p:sldIdLst>
     <p:sldId id="256" r:id="rId2"/>
@@ -14,20 +14,21 @@
     <p:sldId id="259" r:id="rId5"/>
     <p:sldId id="260" r:id="rId6"/>
     <p:sldId id="261" r:id="rId7"/>
-    <p:sldId id="262" r:id="rId8"/>
-    <p:sldId id="271" r:id="rId9"/>
-    <p:sldId id="269" r:id="rId10"/>
-    <p:sldId id="270" r:id="rId11"/>
+    <p:sldId id="271" r:id="rId8"/>
+    <p:sldId id="262" r:id="rId9"/>
+    <p:sldId id="272" r:id="rId10"/>
+    <p:sldId id="269" r:id="rId11"/>
+    <p:sldId id="270" r:id="rId12"/>
   </p:sldIdLst>
   <p:sldSz cx="12192000" cy="6858000"/>
   <p:notesSz cx="6858000" cy="9144000"/>
   <p:embeddedFontLst>
     <p:embeddedFont>
       <p:font typeface="Work Sans" pitchFamily="2" charset="0"/>
-      <p:regular r:id="rId13"/>
-      <p:bold r:id="rId14"/>
-      <p:italic r:id="rId15"/>
-      <p:boldItalic r:id="rId16"/>
+      <p:regular r:id="rId14"/>
+      <p:bold r:id="rId15"/>
+      <p:italic r:id="rId16"/>
+      <p:boldItalic r:id="rId17"/>
     </p:embeddedFont>
   </p:embeddedFontLst>
   <p:defaultTextStyle>
@@ -280,7 +281,7 @@
       </p15:sldGuideLst>
     </p:ext>
     <p:ext uri="GoogleSlidesCustomDataVersion2">
-      <go:slidesCustomData xmlns:go="http://customooxmlschemas.google.com/" xmlns:ahyp="http://schemas.microsoft.com/office/drawing/2018/hyperlinkcolor" xmlns:p15="http://schemas.microsoft.com/office/powerpoint/2012/main" xmlns:p14="http://schemas.microsoft.com/office/powerpoint/2010/main" xmlns:com="http://schemas.openxmlformats.org/drawingml/2006/compatibility" xmlns:pvml="urn:schemas-microsoft-com:office:powerpoint" xmlns:v="urn:schemas-microsoft-com:vml" xmlns:o="urn:schemas-microsoft-com:office:office" xmlns:dgm="http://schemas.openxmlformats.org/drawingml/2006/diagram" xmlns:c="http://schemas.openxmlformats.org/drawingml/2006/chart" xmlns:mv="urn:schemas-microsoft-com:mac:vml" xmlns:mc="http://schemas.openxmlformats.org/markup-compatibility/2006" xmlns="" r:id="rId25" roundtripDataSignature="AMtx7mg93Xqpxt55p6BTs7CMPLVXaSoJtA=="/>
+      <go:slidesCustomData xmlns="" xmlns:mc="http://schemas.openxmlformats.org/markup-compatibility/2006" xmlns:mv="urn:schemas-microsoft-com:mac:vml" xmlns:c="http://schemas.openxmlformats.org/drawingml/2006/chart" xmlns:dgm="http://schemas.openxmlformats.org/drawingml/2006/diagram" xmlns:o="urn:schemas-microsoft-com:office:office" xmlns:v="urn:schemas-microsoft-com:vml" xmlns:pvml="urn:schemas-microsoft-com:office:powerpoint" xmlns:com="http://schemas.openxmlformats.org/drawingml/2006/compatibility" xmlns:p14="http://schemas.microsoft.com/office/powerpoint/2010/main" xmlns:p15="http://schemas.microsoft.com/office/powerpoint/2012/main" xmlns:ahyp="http://schemas.microsoft.com/office/drawing/2018/hyperlinkcolor" xmlns:go="http://customooxmlschemas.google.com/" r:id="rId25" roundtripDataSignature="AMtx7mg93Xqpxt55p6BTs7CMPLVXaSoJtA=="/>
     </p:ext>
   </p:extLst>
 </p:presentation>
@@ -1866,6 +1867,128 @@
   <p:cSld>
     <p:spTree>
       <p:nvGrpSpPr>
+        <p:cNvPr id="1" name="Shape 177"/>
+        <p:cNvGrpSpPr/>
+        <p:nvPr/>
+      </p:nvGrpSpPr>
+      <p:grpSpPr>
+        <a:xfrm>
+          <a:off x="0" y="0"/>
+          <a:ext cx="0" cy="0"/>
+          <a:chOff x="0" y="0"/>
+          <a:chExt cx="0" cy="0"/>
+        </a:xfrm>
+      </p:grpSpPr>
+      <p:sp>
+        <p:nvSpPr>
+          <p:cNvPr id="178" name="Google Shape;178;p34:notes"/>
+          <p:cNvSpPr txBox="1">
+            <a:spLocks noGrp="1"/>
+          </p:cNvSpPr>
+          <p:nvPr>
+            <p:ph type="body" idx="1"/>
+          </p:nvPr>
+        </p:nvSpPr>
+        <p:spPr>
+          <a:xfrm>
+            <a:off x="685800" y="4400550"/>
+            <a:ext cx="5486400" cy="3600450"/>
+          </a:xfrm>
+          <a:prstGeom prst="rect">
+            <a:avLst/>
+          </a:prstGeom>
+          <a:noFill/>
+          <a:ln>
+            <a:noFill/>
+          </a:ln>
+        </p:spPr>
+        <p:txBody>
+          <a:bodyPr spcFirstLastPara="1" wrap="square" lIns="91425" tIns="45700" rIns="91425" bIns="45700" anchor="t" anchorCtr="0">
+            <a:noAutofit/>
+          </a:bodyPr>
+          <a:lstStyle/>
+          <a:p>
+            <a:pPr marL="0" lvl="0" indent="0" algn="l" rtl="0">
+              <a:lnSpc>
+                <a:spcPct val="100000"/>
+              </a:lnSpc>
+              <a:spcBef>
+                <a:spcPts val="0"/>
+              </a:spcBef>
+              <a:spcAft>
+                <a:spcPts val="0"/>
+              </a:spcAft>
+              <a:buSzPts val="1400"/>
+              <a:buNone/>
+            </a:pPr>
+            <a:endParaRPr/>
+          </a:p>
+        </p:txBody>
+      </p:sp>
+      <p:sp>
+        <p:nvSpPr>
+          <p:cNvPr id="179" name="Google Shape;179;p34:notes"/>
+          <p:cNvSpPr>
+            <a:spLocks noGrp="1" noRot="1" noChangeAspect="1"/>
+          </p:cNvSpPr>
+          <p:nvPr>
+            <p:ph type="sldImg" idx="2"/>
+          </p:nvPr>
+        </p:nvSpPr>
+        <p:spPr>
+          <a:xfrm>
+            <a:off x="685800" y="1143000"/>
+            <a:ext cx="5486400" cy="3086100"/>
+          </a:xfrm>
+          <a:custGeom>
+            <a:avLst/>
+            <a:gdLst/>
+            <a:ahLst/>
+            <a:cxnLst/>
+            <a:rect l="l" t="t" r="r" b="b"/>
+            <a:pathLst>
+              <a:path w="120000" h="120000" extrusionOk="0">
+                <a:moveTo>
+                  <a:pt x="0" y="0"/>
+                </a:moveTo>
+                <a:lnTo>
+                  <a:pt x="120000" y="0"/>
+                </a:lnTo>
+                <a:lnTo>
+                  <a:pt x="120000" y="120000"/>
+                </a:lnTo>
+                <a:lnTo>
+                  <a:pt x="0" y="120000"/>
+                </a:lnTo>
+                <a:close/>
+              </a:path>
+            </a:pathLst>
+          </a:custGeom>
+          <a:noFill/>
+          <a:ln w="12700" cap="flat" cmpd="sng">
+            <a:solidFill>
+              <a:srgbClr val="000000"/>
+            </a:solidFill>
+            <a:prstDash val="solid"/>
+            <a:round/>
+            <a:headEnd type="none" w="sm" len="sm"/>
+            <a:tailEnd type="none" w="sm" len="sm"/>
+          </a:ln>
+        </p:spPr>
+      </p:sp>
+    </p:spTree>
+  </p:cSld>
+  <p:clrMapOvr>
+    <a:masterClrMapping/>
+  </p:clrMapOvr>
+</p:notes>
+</file>
+
+<file path=ppt/notesSlides/notesSlide11.xml><?xml version="1.0" encoding="utf-8"?>
+<p:notes xmlns:a="http://schemas.openxmlformats.org/drawingml/2006/main" xmlns:r="http://schemas.openxmlformats.org/officeDocument/2006/relationships" xmlns:p="http://schemas.openxmlformats.org/presentationml/2006/main" showMasterSp="0" showMasterPhAnim="0">
+  <p:cSld>
+    <p:spTree>
+      <p:nvGrpSpPr>
         <p:cNvPr id="1" name="Shape 183"/>
         <p:cNvGrpSpPr/>
         <p:nvPr/>
@@ -2598,128 +2721,6 @@
   <p:cSld>
     <p:spTree>
       <p:nvGrpSpPr>
-        <p:cNvPr id="1" name="Shape 129"/>
-        <p:cNvGrpSpPr/>
-        <p:nvPr/>
-      </p:nvGrpSpPr>
-      <p:grpSpPr>
-        <a:xfrm>
-          <a:off x="0" y="0"/>
-          <a:ext cx="0" cy="0"/>
-          <a:chOff x="0" y="0"/>
-          <a:chExt cx="0" cy="0"/>
-        </a:xfrm>
-      </p:grpSpPr>
-      <p:sp>
-        <p:nvSpPr>
-          <p:cNvPr id="130" name="Google Shape;130;p7:notes"/>
-          <p:cNvSpPr txBox="1">
-            <a:spLocks noGrp="1"/>
-          </p:cNvSpPr>
-          <p:nvPr>
-            <p:ph type="body" idx="1"/>
-          </p:nvPr>
-        </p:nvSpPr>
-        <p:spPr>
-          <a:xfrm>
-            <a:off x="685800" y="4400550"/>
-            <a:ext cx="5486400" cy="3600450"/>
-          </a:xfrm>
-          <a:prstGeom prst="rect">
-            <a:avLst/>
-          </a:prstGeom>
-          <a:noFill/>
-          <a:ln>
-            <a:noFill/>
-          </a:ln>
-        </p:spPr>
-        <p:txBody>
-          <a:bodyPr spcFirstLastPara="1" wrap="square" lIns="91425" tIns="45700" rIns="91425" bIns="45700" anchor="t" anchorCtr="0">
-            <a:noAutofit/>
-          </a:bodyPr>
-          <a:lstStyle/>
-          <a:p>
-            <a:pPr marL="0" lvl="0" indent="0" algn="l" rtl="0">
-              <a:lnSpc>
-                <a:spcPct val="100000"/>
-              </a:lnSpc>
-              <a:spcBef>
-                <a:spcPts val="0"/>
-              </a:spcBef>
-              <a:spcAft>
-                <a:spcPts val="0"/>
-              </a:spcAft>
-              <a:buSzPts val="1400"/>
-              <a:buNone/>
-            </a:pPr>
-            <a:endParaRPr/>
-          </a:p>
-        </p:txBody>
-      </p:sp>
-      <p:sp>
-        <p:nvSpPr>
-          <p:cNvPr id="131" name="Google Shape;131;p7:notes"/>
-          <p:cNvSpPr>
-            <a:spLocks noGrp="1" noRot="1" noChangeAspect="1"/>
-          </p:cNvSpPr>
-          <p:nvPr>
-            <p:ph type="sldImg" idx="2"/>
-          </p:nvPr>
-        </p:nvSpPr>
-        <p:spPr>
-          <a:xfrm>
-            <a:off x="685800" y="1143000"/>
-            <a:ext cx="5486400" cy="3086100"/>
-          </a:xfrm>
-          <a:custGeom>
-            <a:avLst/>
-            <a:gdLst/>
-            <a:ahLst/>
-            <a:cxnLst/>
-            <a:rect l="l" t="t" r="r" b="b"/>
-            <a:pathLst>
-              <a:path w="120000" h="120000" extrusionOk="0">
-                <a:moveTo>
-                  <a:pt x="0" y="0"/>
-                </a:moveTo>
-                <a:lnTo>
-                  <a:pt x="120000" y="0"/>
-                </a:lnTo>
-                <a:lnTo>
-                  <a:pt x="120000" y="120000"/>
-                </a:lnTo>
-                <a:lnTo>
-                  <a:pt x="0" y="120000"/>
-                </a:lnTo>
-                <a:close/>
-              </a:path>
-            </a:pathLst>
-          </a:custGeom>
-          <a:noFill/>
-          <a:ln w="12700" cap="flat" cmpd="sng">
-            <a:solidFill>
-              <a:srgbClr val="000000"/>
-            </a:solidFill>
-            <a:prstDash val="solid"/>
-            <a:round/>
-            <a:headEnd type="none" w="sm" len="sm"/>
-            <a:tailEnd type="none" w="sm" len="sm"/>
-          </a:ln>
-        </p:spPr>
-      </p:sp>
-    </p:spTree>
-  </p:cSld>
-  <p:clrMapOvr>
-    <a:masterClrMapping/>
-  </p:clrMapOvr>
-</p:notes>
-</file>
-
-<file path=ppt/notesSlides/notesSlide8.xml><?xml version="1.0" encoding="utf-8"?>
-<p:notes xmlns:a="http://schemas.openxmlformats.org/drawingml/2006/main" xmlns:r="http://schemas.openxmlformats.org/officeDocument/2006/relationships" xmlns:p="http://schemas.openxmlformats.org/presentationml/2006/main" showMasterSp="0" showMasterPhAnim="0">
-  <p:cSld>
-    <p:spTree>
-      <p:nvGrpSpPr>
         <p:cNvPr id="1" name="Shape 129">
           <a:extLst>
             <a:ext uri="{FF2B5EF4-FFF2-40B4-BE49-F238E27FC236}">
@@ -2860,12 +2861,12 @@
 </p:notes>
 </file>
 
-<file path=ppt/notesSlides/notesSlide9.xml><?xml version="1.0" encoding="utf-8"?>
+<file path=ppt/notesSlides/notesSlide8.xml><?xml version="1.0" encoding="utf-8"?>
 <p:notes xmlns:a="http://schemas.openxmlformats.org/drawingml/2006/main" xmlns:r="http://schemas.openxmlformats.org/officeDocument/2006/relationships" xmlns:p="http://schemas.openxmlformats.org/presentationml/2006/main" showMasterSp="0" showMasterPhAnim="0">
   <p:cSld>
     <p:spTree>
       <p:nvGrpSpPr>
-        <p:cNvPr id="1" name="Shape 177"/>
+        <p:cNvPr id="1" name="Shape 129"/>
         <p:cNvGrpSpPr/>
         <p:nvPr/>
       </p:nvGrpSpPr>
@@ -2879,7 +2880,7 @@
       </p:grpSpPr>
       <p:sp>
         <p:nvSpPr>
-          <p:cNvPr id="178" name="Google Shape;178;p34:notes"/>
+          <p:cNvPr id="130" name="Google Shape;130;p7:notes"/>
           <p:cNvSpPr txBox="1">
             <a:spLocks noGrp="1"/>
           </p:cNvSpPr>
@@ -2925,7 +2926,7 @@
       </p:sp>
       <p:sp>
         <p:nvSpPr>
-          <p:cNvPr id="179" name="Google Shape;179;p34:notes"/>
+          <p:cNvPr id="131" name="Google Shape;131;p7:notes"/>
           <p:cNvSpPr>
             <a:spLocks noGrp="1" noRot="1" noChangeAspect="1"/>
           </p:cNvSpPr>
@@ -2975,6 +2976,151 @@
         </p:spPr>
       </p:sp>
     </p:spTree>
+  </p:cSld>
+  <p:clrMapOvr>
+    <a:masterClrMapping/>
+  </p:clrMapOvr>
+</p:notes>
+</file>
+
+<file path=ppt/notesSlides/notesSlide9.xml><?xml version="1.0" encoding="utf-8"?>
+<p:notes xmlns:a="http://schemas.openxmlformats.org/drawingml/2006/main" xmlns:r="http://schemas.openxmlformats.org/officeDocument/2006/relationships" xmlns:p="http://schemas.openxmlformats.org/presentationml/2006/main" showMasterSp="0" showMasterPhAnim="0">
+  <p:cSld>
+    <p:spTree>
+      <p:nvGrpSpPr>
+        <p:cNvPr id="1" name="Shape 129">
+          <a:extLst>
+            <a:ext uri="{FF2B5EF4-FFF2-40B4-BE49-F238E27FC236}">
+              <a16:creationId xmlns:a16="http://schemas.microsoft.com/office/drawing/2014/main" id="{9C6B4C5F-7C6C-8A02-8D9A-3640868FCA4A}"/>
+            </a:ext>
+          </a:extLst>
+        </p:cNvPr>
+        <p:cNvGrpSpPr/>
+        <p:nvPr/>
+      </p:nvGrpSpPr>
+      <p:grpSpPr>
+        <a:xfrm>
+          <a:off x="0" y="0"/>
+          <a:ext cx="0" cy="0"/>
+          <a:chOff x="0" y="0"/>
+          <a:chExt cx="0" cy="0"/>
+        </a:xfrm>
+      </p:grpSpPr>
+      <p:sp>
+        <p:nvSpPr>
+          <p:cNvPr id="130" name="Google Shape;130;p7:notes">
+            <a:extLst>
+              <a:ext uri="{FF2B5EF4-FFF2-40B4-BE49-F238E27FC236}">
+                <a16:creationId xmlns:a16="http://schemas.microsoft.com/office/drawing/2014/main" id="{922F3117-BD8D-F9EE-112F-74A5F88F5ED7}"/>
+              </a:ext>
+            </a:extLst>
+          </p:cNvPr>
+          <p:cNvSpPr txBox="1">
+            <a:spLocks noGrp="1"/>
+          </p:cNvSpPr>
+          <p:nvPr>
+            <p:ph type="body" idx="1"/>
+          </p:nvPr>
+        </p:nvSpPr>
+        <p:spPr>
+          <a:xfrm>
+            <a:off x="685800" y="4400550"/>
+            <a:ext cx="5486400" cy="3600450"/>
+          </a:xfrm>
+          <a:prstGeom prst="rect">
+            <a:avLst/>
+          </a:prstGeom>
+          <a:noFill/>
+          <a:ln>
+            <a:noFill/>
+          </a:ln>
+        </p:spPr>
+        <p:txBody>
+          <a:bodyPr spcFirstLastPara="1" wrap="square" lIns="91425" tIns="45700" rIns="91425" bIns="45700" anchor="t" anchorCtr="0">
+            <a:noAutofit/>
+          </a:bodyPr>
+          <a:lstStyle/>
+          <a:p>
+            <a:pPr marL="0" lvl="0" indent="0" algn="l" rtl="0">
+              <a:lnSpc>
+                <a:spcPct val="100000"/>
+              </a:lnSpc>
+              <a:spcBef>
+                <a:spcPts val="0"/>
+              </a:spcBef>
+              <a:spcAft>
+                <a:spcPts val="0"/>
+              </a:spcAft>
+              <a:buSzPts val="1400"/>
+              <a:buNone/>
+            </a:pPr>
+            <a:endParaRPr/>
+          </a:p>
+        </p:txBody>
+      </p:sp>
+      <p:sp>
+        <p:nvSpPr>
+          <p:cNvPr id="131" name="Google Shape;131;p7:notes">
+            <a:extLst>
+              <a:ext uri="{FF2B5EF4-FFF2-40B4-BE49-F238E27FC236}">
+                <a16:creationId xmlns:a16="http://schemas.microsoft.com/office/drawing/2014/main" id="{95894209-1BFD-07B6-238B-C868E3EB411F}"/>
+              </a:ext>
+            </a:extLst>
+          </p:cNvPr>
+          <p:cNvSpPr>
+            <a:spLocks noGrp="1" noRot="1" noChangeAspect="1"/>
+          </p:cNvSpPr>
+          <p:nvPr>
+            <p:ph type="sldImg" idx="2"/>
+          </p:nvPr>
+        </p:nvSpPr>
+        <p:spPr>
+          <a:xfrm>
+            <a:off x="685800" y="1143000"/>
+            <a:ext cx="5486400" cy="3086100"/>
+          </a:xfrm>
+          <a:custGeom>
+            <a:avLst/>
+            <a:gdLst/>
+            <a:ahLst/>
+            <a:cxnLst/>
+            <a:rect l="l" t="t" r="r" b="b"/>
+            <a:pathLst>
+              <a:path w="120000" h="120000" extrusionOk="0">
+                <a:moveTo>
+                  <a:pt x="0" y="0"/>
+                </a:moveTo>
+                <a:lnTo>
+                  <a:pt x="120000" y="0"/>
+                </a:lnTo>
+                <a:lnTo>
+                  <a:pt x="120000" y="120000"/>
+                </a:lnTo>
+                <a:lnTo>
+                  <a:pt x="0" y="120000"/>
+                </a:lnTo>
+                <a:close/>
+              </a:path>
+            </a:pathLst>
+          </a:custGeom>
+          <a:noFill/>
+          <a:ln w="12700" cap="flat" cmpd="sng">
+            <a:solidFill>
+              <a:srgbClr val="000000"/>
+            </a:solidFill>
+            <a:prstDash val="solid"/>
+            <a:round/>
+            <a:headEnd type="none" w="sm" len="sm"/>
+            <a:tailEnd type="none" w="sm" len="sm"/>
+          </a:ln>
+        </p:spPr>
+      </p:sp>
+    </p:spTree>
+    <p:extLst>
+      <p:ext uri="{BB962C8B-B14F-4D97-AF65-F5344CB8AC3E}">
+        <p14:creationId xmlns:p14="http://schemas.microsoft.com/office/powerpoint/2010/main" val="808552073"/>
+      </p:ext>
+    </p:extLst>
   </p:cSld>
   <p:clrMapOvr>
     <a:masterClrMapping/>
@@ -17052,6 +17198,131 @@
     </p:bg>
     <p:spTree>
       <p:nvGrpSpPr>
+        <p:cNvPr id="1" name="Shape 180"/>
+        <p:cNvGrpSpPr/>
+        <p:nvPr/>
+      </p:nvGrpSpPr>
+      <p:grpSpPr>
+        <a:xfrm>
+          <a:off x="0" y="0"/>
+          <a:ext cx="0" cy="0"/>
+          <a:chOff x="0" y="0"/>
+          <a:chExt cx="0" cy="0"/>
+        </a:xfrm>
+      </p:grpSpPr>
+      <p:sp>
+        <p:nvSpPr>
+          <p:cNvPr id="181" name="Google Shape;181;p34"/>
+          <p:cNvSpPr txBox="1"/>
+          <p:nvPr/>
+        </p:nvSpPr>
+        <p:spPr>
+          <a:xfrm>
+            <a:off x="399535" y="2287246"/>
+            <a:ext cx="11392931" cy="1015622"/>
+          </a:xfrm>
+          <a:prstGeom prst="rect">
+            <a:avLst/>
+          </a:prstGeom>
+          <a:noFill/>
+          <a:ln>
+            <a:noFill/>
+          </a:ln>
+        </p:spPr>
+        <p:txBody>
+          <a:bodyPr spcFirstLastPara="1" wrap="square" lIns="91425" tIns="45700" rIns="91425" bIns="45700" anchor="t" anchorCtr="0">
+            <a:spAutoFit/>
+          </a:bodyPr>
+          <a:lstStyle/>
+          <a:p>
+            <a:pPr marL="0" marR="0" lvl="0" indent="0" algn="ctr" rtl="0">
+              <a:lnSpc>
+                <a:spcPct val="100000"/>
+              </a:lnSpc>
+              <a:spcBef>
+                <a:spcPts val="0"/>
+              </a:spcBef>
+              <a:spcAft>
+                <a:spcPts val="0"/>
+              </a:spcAft>
+              <a:buNone/>
+            </a:pPr>
+            <a:r>
+              <a:rPr lang="es-CO" sz="6000" b="1" dirty="0" err="1">
+                <a:solidFill>
+                  <a:schemeClr val="lt1"/>
+                </a:solidFill>
+                <a:latin typeface="Work Sans"/>
+                <a:ea typeface="Work Sans"/>
+                <a:cs typeface="Work Sans"/>
+                <a:sym typeface="Work Sans"/>
+              </a:rPr>
+              <a:t>React</a:t>
+            </a:r>
+            <a:endParaRPr sz="7200" b="1" i="0" u="none" strike="noStrike" cap="none" dirty="0">
+              <a:solidFill>
+                <a:schemeClr val="lt1"/>
+              </a:solidFill>
+              <a:latin typeface="Work Sans"/>
+              <a:ea typeface="Work Sans"/>
+              <a:cs typeface="Work Sans"/>
+              <a:sym typeface="Work Sans"/>
+            </a:endParaRPr>
+          </a:p>
+        </p:txBody>
+      </p:sp>
+      <p:cxnSp>
+        <p:nvCxnSpPr>
+          <p:cNvPr id="182" name="Google Shape;182;p34"/>
+          <p:cNvCxnSpPr/>
+          <p:nvPr/>
+        </p:nvCxnSpPr>
+        <p:spPr>
+          <a:xfrm>
+            <a:off x="5013631" y="3555133"/>
+            <a:ext cx="2247544" cy="0"/>
+          </a:xfrm>
+          <a:prstGeom prst="straightConnector1">
+            <a:avLst/>
+          </a:prstGeom>
+          <a:noFill/>
+          <a:ln w="12700" cap="flat" cmpd="sng">
+            <a:solidFill>
+              <a:schemeClr val="lt1"/>
+            </a:solidFill>
+            <a:prstDash val="solid"/>
+            <a:miter lim="8000"/>
+            <a:headEnd type="none" w="sm" len="sm"/>
+            <a:tailEnd type="none" w="sm" len="sm"/>
+          </a:ln>
+        </p:spPr>
+      </p:cxnSp>
+    </p:spTree>
+  </p:cSld>
+  <p:clrMapOvr>
+    <a:masterClrMapping/>
+  </p:clrMapOvr>
+</p:sld>
+</file>
+
+<file path=ppt/slides/slide11.xml><?xml version="1.0" encoding="utf-8"?>
+<p:sld xmlns:a="http://schemas.openxmlformats.org/drawingml/2006/main" xmlns:r="http://schemas.openxmlformats.org/officeDocument/2006/relationships" xmlns:p="http://schemas.openxmlformats.org/presentationml/2006/main">
+  <p:cSld>
+    <p:bg>
+      <p:bgPr>
+        <a:blipFill>
+          <a:blip r:embed="rId3">
+            <a:alphaModFix/>
+          </a:blip>
+          <a:stretch>
+            <a:fillRect/>
+          </a:stretch>
+        </a:blipFill>
+        <a:effectLst/>
+      </p:bgPr>
+    </p:bg>
+    <p:spTree>
+      <p:nvGrpSpPr>
         <p:cNvPr id="1" name="Shape 186"/>
         <p:cNvGrpSpPr/>
         <p:nvPr/>
@@ -17482,7 +17753,7 @@
               <a:buNone/>
             </a:pPr>
             <a:r>
-              <a:rPr lang="es-CO" sz="3600" b="0" i="0" u="none" strike="noStrike" cap="none">
+              <a:rPr lang="es-CO" sz="3600" b="0" i="0" u="none" strike="noStrike" cap="none" dirty="0">
                 <a:solidFill>
                   <a:schemeClr val="dk1"/>
                 </a:solidFill>
@@ -17491,9 +17762,33 @@
                 <a:cs typeface="Calibri"/>
                 <a:sym typeface="Calibri"/>
               </a:rPr>
-              <a:t>Desarrollar una aplicación que gestione los pedidos, el inventario y la generación de recibos, facilitando la organización de la producción y las entregas en Oro Pan.</a:t>
+              <a:t>Desarrollar una aplicación que gestione los</a:t>
             </a:r>
-            <a:endParaRPr sz="1400" b="0" i="0" u="none" strike="noStrike" cap="none">
+            <a:r>
+              <a:rPr lang="es-CO" sz="3600" dirty="0">
+                <a:solidFill>
+                  <a:schemeClr val="dk1"/>
+                </a:solidFill>
+                <a:latin typeface="Calibri"/>
+                <a:ea typeface="Calibri"/>
+                <a:cs typeface="Calibri"/>
+                <a:sym typeface="Calibri"/>
+              </a:rPr>
+              <a:t> usuarios,</a:t>
+            </a:r>
+            <a:r>
+              <a:rPr lang="es-CO" sz="3600" b="0" i="0" u="none" strike="noStrike" cap="none" dirty="0">
+                <a:solidFill>
+                  <a:schemeClr val="dk1"/>
+                </a:solidFill>
+                <a:latin typeface="Calibri"/>
+                <a:ea typeface="Calibri"/>
+                <a:cs typeface="Calibri"/>
+                <a:sym typeface="Calibri"/>
+              </a:rPr>
+              <a:t> pedidos, el inventario y la generación de recibos, facilitando la organización de la producción y las entregas en Oro Pan.</a:t>
+            </a:r>
+            <a:endParaRPr sz="1400" b="0" i="0" u="none" strike="noStrike" cap="none" dirty="0">
               <a:solidFill>
                 <a:srgbClr val="000000"/>
               </a:solidFill>
@@ -17959,6 +18254,220 @@
     </p:bg>
     <p:spTree>
       <p:nvGrpSpPr>
+        <p:cNvPr id="1" name="Shape 132">
+          <a:extLst>
+            <a:ext uri="{FF2B5EF4-FFF2-40B4-BE49-F238E27FC236}">
+              <a16:creationId xmlns:a16="http://schemas.microsoft.com/office/drawing/2014/main" id="{02282304-6915-C422-6C07-E2BE4DFB14BE}"/>
+            </a:ext>
+          </a:extLst>
+        </p:cNvPr>
+        <p:cNvGrpSpPr/>
+        <p:nvPr/>
+      </p:nvGrpSpPr>
+      <p:grpSpPr>
+        <a:xfrm>
+          <a:off x="0" y="0"/>
+          <a:ext cx="0" cy="0"/>
+          <a:chOff x="0" y="0"/>
+          <a:chExt cx="0" cy="0"/>
+        </a:xfrm>
+      </p:grpSpPr>
+      <p:sp>
+        <p:nvSpPr>
+          <p:cNvPr id="133" name="Google Shape;133;p7">
+            <a:extLst>
+              <a:ext uri="{FF2B5EF4-FFF2-40B4-BE49-F238E27FC236}">
+                <a16:creationId xmlns:a16="http://schemas.microsoft.com/office/drawing/2014/main" id="{5A7C9754-119D-E833-66BC-2E6B47D287CF}"/>
+              </a:ext>
+            </a:extLst>
+          </p:cNvPr>
+          <p:cNvSpPr txBox="1"/>
+          <p:nvPr/>
+        </p:nvSpPr>
+        <p:spPr>
+          <a:xfrm>
+            <a:off x="653143" y="325249"/>
+            <a:ext cx="9940835" cy="527875"/>
+          </a:xfrm>
+          <a:prstGeom prst="rect">
+            <a:avLst/>
+          </a:prstGeom>
+          <a:noFill/>
+          <a:ln>
+            <a:noFill/>
+          </a:ln>
+        </p:spPr>
+        <p:txBody>
+          <a:bodyPr spcFirstLastPara="1" wrap="square" lIns="91425" tIns="45700" rIns="91425" bIns="45700" anchor="t" anchorCtr="0">
+            <a:noAutofit/>
+          </a:bodyPr>
+          <a:lstStyle/>
+          <a:p>
+            <a:pPr marL="0" marR="0" lvl="0" indent="0" algn="l" rtl="0">
+              <a:lnSpc>
+                <a:spcPct val="100000"/>
+              </a:lnSpc>
+              <a:spcBef>
+                <a:spcPts val="0"/>
+              </a:spcBef>
+              <a:spcAft>
+                <a:spcPts val="0"/>
+              </a:spcAft>
+              <a:buNone/>
+            </a:pPr>
+            <a:r>
+              <a:rPr lang="es-CO" sz="4000" b="1" i="0" u="none" strike="noStrike" cap="none" dirty="0">
+                <a:solidFill>
+                  <a:srgbClr val="FFFFFF"/>
+                </a:solidFill>
+                <a:latin typeface="Work Sans"/>
+                <a:ea typeface="Work Sans"/>
+                <a:cs typeface="Work Sans"/>
+                <a:sym typeface="Work Sans"/>
+              </a:rPr>
+              <a:t>Modelo Relacional</a:t>
+            </a:r>
+            <a:endParaRPr sz="4000" b="1" i="0" u="none" strike="noStrike" cap="none" dirty="0">
+              <a:solidFill>
+                <a:srgbClr val="FFFFFF"/>
+              </a:solidFill>
+              <a:latin typeface="Work Sans"/>
+              <a:ea typeface="Work Sans"/>
+              <a:cs typeface="Work Sans"/>
+              <a:sym typeface="Work Sans"/>
+            </a:endParaRPr>
+          </a:p>
+        </p:txBody>
+      </p:sp>
+      <p:sp>
+        <p:nvSpPr>
+          <p:cNvPr id="134" name="Google Shape;134;p7">
+            <a:extLst>
+              <a:ext uri="{FF2B5EF4-FFF2-40B4-BE49-F238E27FC236}">
+                <a16:creationId xmlns:a16="http://schemas.microsoft.com/office/drawing/2014/main" id="{0B41B283-608F-71B7-FC78-616FA33054D3}"/>
+              </a:ext>
+            </a:extLst>
+          </p:cNvPr>
+          <p:cNvSpPr txBox="1"/>
+          <p:nvPr/>
+        </p:nvSpPr>
+        <p:spPr>
+          <a:xfrm>
+            <a:off x="7611526" y="3497945"/>
+            <a:ext cx="3696939" cy="646290"/>
+          </a:xfrm>
+          <a:prstGeom prst="rect">
+            <a:avLst/>
+          </a:prstGeom>
+          <a:noFill/>
+          <a:ln>
+            <a:noFill/>
+          </a:ln>
+        </p:spPr>
+        <p:txBody>
+          <a:bodyPr spcFirstLastPara="1" wrap="square" lIns="91425" tIns="45700" rIns="91425" bIns="45700" anchor="t" anchorCtr="0">
+            <a:spAutoFit/>
+          </a:bodyPr>
+          <a:lstStyle/>
+          <a:p>
+            <a:pPr marL="0" marR="0" lvl="0" indent="0" algn="l" rtl="0">
+              <a:lnSpc>
+                <a:spcPct val="100000"/>
+              </a:lnSpc>
+              <a:spcBef>
+                <a:spcPts val="0"/>
+              </a:spcBef>
+              <a:spcAft>
+                <a:spcPts val="0"/>
+              </a:spcAft>
+              <a:buNone/>
+            </a:pPr>
+            <a:r>
+              <a:rPr lang="es-CO" sz="3600" u="sng" dirty="0">
+                <a:solidFill>
+                  <a:schemeClr val="accent6"/>
+                </a:solidFill>
+                <a:latin typeface="Calibri"/>
+                <a:ea typeface="Calibri"/>
+                <a:cs typeface="Calibri"/>
+                <a:sym typeface="Calibri"/>
+                <a:hlinkClick r:id="rId4"/>
+              </a:rPr>
+              <a:t>Modelo Relacional</a:t>
+            </a:r>
+            <a:endParaRPr sz="1400" b="0" i="0" u="none" strike="noStrike" cap="none" dirty="0">
+              <a:solidFill>
+                <a:schemeClr val="accent6"/>
+              </a:solidFill>
+              <a:latin typeface="Arial"/>
+              <a:ea typeface="Arial"/>
+              <a:cs typeface="Arial"/>
+              <a:sym typeface="Arial"/>
+            </a:endParaRPr>
+          </a:p>
+        </p:txBody>
+      </p:sp>
+      <p:pic>
+        <p:nvPicPr>
+          <p:cNvPr id="4" name="Imagen 3">
+            <a:extLst>
+              <a:ext uri="{FF2B5EF4-FFF2-40B4-BE49-F238E27FC236}">
+                <a16:creationId xmlns:a16="http://schemas.microsoft.com/office/drawing/2014/main" id="{F708692A-D63B-7AAC-9F4C-BC53D165FB47}"/>
+              </a:ext>
+            </a:extLst>
+          </p:cNvPr>
+          <p:cNvPicPr>
+            <a:picLocks noChangeAspect="1"/>
+          </p:cNvPicPr>
+          <p:nvPr/>
+        </p:nvPicPr>
+        <p:blipFill>
+          <a:blip r:embed="rId5"/>
+          <a:stretch>
+            <a:fillRect/>
+          </a:stretch>
+        </p:blipFill>
+        <p:spPr>
+          <a:xfrm>
+            <a:off x="326404" y="1338179"/>
+            <a:ext cx="5889570" cy="5519821"/>
+          </a:xfrm>
+          <a:prstGeom prst="rect">
+            <a:avLst/>
+          </a:prstGeom>
+        </p:spPr>
+      </p:pic>
+    </p:spTree>
+    <p:extLst>
+      <p:ext uri="{BB962C8B-B14F-4D97-AF65-F5344CB8AC3E}">
+        <p14:creationId xmlns:p14="http://schemas.microsoft.com/office/powerpoint/2010/main" val="3346515751"/>
+      </p:ext>
+    </p:extLst>
+  </p:cSld>
+  <p:clrMapOvr>
+    <a:masterClrMapping/>
+  </p:clrMapOvr>
+</p:sld>
+</file>
+
+<file path=ppt/slides/slide8.xml><?xml version="1.0" encoding="utf-8"?>
+<p:sld xmlns:a="http://schemas.openxmlformats.org/drawingml/2006/main" xmlns:r="http://schemas.openxmlformats.org/officeDocument/2006/relationships" xmlns:p="http://schemas.openxmlformats.org/presentationml/2006/main">
+  <p:cSld>
+    <p:bg>
+      <p:bgPr>
+        <a:blipFill>
+          <a:blip r:embed="rId3">
+            <a:alphaModFix/>
+          </a:blip>
+          <a:stretch>
+            <a:fillRect/>
+          </a:stretch>
+        </a:blipFill>
+        <a:effectLst/>
+      </p:bgPr>
+    </p:bg>
+    <p:spTree>
+      <p:nvGrpSpPr>
         <p:cNvPr id="1" name="Shape 132"/>
         <p:cNvGrpSpPr/>
         <p:nvPr/>
@@ -18144,7 +18653,7 @@
 </p:sld>
 </file>
 
-<file path=ppt/slides/slide8.xml><?xml version="1.0" encoding="utf-8"?>
+<file path=ppt/slides/slide9.xml><?xml version="1.0" encoding="utf-8"?>
 <p:sld xmlns:a="http://schemas.openxmlformats.org/drawingml/2006/main" xmlns:r="http://schemas.openxmlformats.org/officeDocument/2006/relationships" xmlns:p="http://schemas.openxmlformats.org/presentationml/2006/main">
   <p:cSld>
     <p:bg>
@@ -18233,7 +18742,7 @@
                 <a:cs typeface="Work Sans"/>
                 <a:sym typeface="Work Sans"/>
               </a:rPr>
-              <a:t>Modelo Relacional</a:t>
+              <a:t>Consultas</a:t>
             </a:r>
             <a:endParaRPr sz="4000" b="1" i="0" u="none" strike="noStrike" cap="none" dirty="0">
               <a:solidFill>
@@ -18262,7 +18771,7 @@
         <p:spPr>
           <a:xfrm>
             <a:off x="8479628" y="3451799"/>
-            <a:ext cx="1714959" cy="646290"/>
+            <a:ext cx="2114350" cy="646290"/>
           </a:xfrm>
           <a:prstGeom prst="rect">
             <a:avLst/>
@@ -18299,9 +18808,8 @@
                 <a:ea typeface="Calibri"/>
                 <a:cs typeface="Calibri"/>
                 <a:sym typeface="Calibri"/>
-                <a:hlinkClick r:id="rId4"/>
               </a:rPr>
-              <a:t>Modelo</a:t>
+              <a:t>Consultas</a:t>
             </a:r>
             <a:endParaRPr sz="1400" b="0" i="0" u="none" strike="noStrike" cap="none" dirty="0">
               <a:solidFill>
@@ -18315,167 +18823,12 @@
           </a:p>
         </p:txBody>
       </p:sp>
-      <p:pic>
-        <p:nvPicPr>
-          <p:cNvPr id="4" name="Imagen 3">
-            <a:extLst>
-              <a:ext uri="{FF2B5EF4-FFF2-40B4-BE49-F238E27FC236}">
-                <a16:creationId xmlns:a16="http://schemas.microsoft.com/office/drawing/2014/main" id="{F708692A-D63B-7AAC-9F4C-BC53D165FB47}"/>
-              </a:ext>
-            </a:extLst>
-          </p:cNvPr>
-          <p:cNvPicPr>
-            <a:picLocks noChangeAspect="1"/>
-          </p:cNvPicPr>
-          <p:nvPr/>
-        </p:nvPicPr>
-        <p:blipFill>
-          <a:blip r:embed="rId5"/>
-          <a:stretch>
-            <a:fillRect/>
-          </a:stretch>
-        </p:blipFill>
-        <p:spPr>
-          <a:xfrm>
-            <a:off x="326404" y="1338179"/>
-            <a:ext cx="5889570" cy="5519821"/>
-          </a:xfrm>
-          <a:prstGeom prst="rect">
-            <a:avLst/>
-          </a:prstGeom>
-        </p:spPr>
-      </p:pic>
     </p:spTree>
     <p:extLst>
       <p:ext uri="{BB962C8B-B14F-4D97-AF65-F5344CB8AC3E}">
-        <p14:creationId xmlns:p14="http://schemas.microsoft.com/office/powerpoint/2010/main" val="3346515751"/>
+        <p14:creationId xmlns:p14="http://schemas.microsoft.com/office/powerpoint/2010/main" val="4103427487"/>
       </p:ext>
     </p:extLst>
-  </p:cSld>
-  <p:clrMapOvr>
-    <a:masterClrMapping/>
-  </p:clrMapOvr>
-</p:sld>
-</file>
-
-<file path=ppt/slides/slide9.xml><?xml version="1.0" encoding="utf-8"?>
-<p:sld xmlns:a="http://schemas.openxmlformats.org/drawingml/2006/main" xmlns:r="http://schemas.openxmlformats.org/officeDocument/2006/relationships" xmlns:p="http://schemas.openxmlformats.org/presentationml/2006/main">
-  <p:cSld>
-    <p:bg>
-      <p:bgPr>
-        <a:blipFill>
-          <a:blip r:embed="rId3">
-            <a:alphaModFix/>
-          </a:blip>
-          <a:stretch>
-            <a:fillRect/>
-          </a:stretch>
-        </a:blipFill>
-        <a:effectLst/>
-      </p:bgPr>
-    </p:bg>
-    <p:spTree>
-      <p:nvGrpSpPr>
-        <p:cNvPr id="1" name="Shape 180"/>
-        <p:cNvGrpSpPr/>
-        <p:nvPr/>
-      </p:nvGrpSpPr>
-      <p:grpSpPr>
-        <a:xfrm>
-          <a:off x="0" y="0"/>
-          <a:ext cx="0" cy="0"/>
-          <a:chOff x="0" y="0"/>
-          <a:chExt cx="0" cy="0"/>
-        </a:xfrm>
-      </p:grpSpPr>
-      <p:sp>
-        <p:nvSpPr>
-          <p:cNvPr id="181" name="Google Shape;181;p34"/>
-          <p:cNvSpPr txBox="1"/>
-          <p:nvPr/>
-        </p:nvSpPr>
-        <p:spPr>
-          <a:xfrm>
-            <a:off x="399535" y="2287246"/>
-            <a:ext cx="11392931" cy="1015622"/>
-          </a:xfrm>
-          <a:prstGeom prst="rect">
-            <a:avLst/>
-          </a:prstGeom>
-          <a:noFill/>
-          <a:ln>
-            <a:noFill/>
-          </a:ln>
-        </p:spPr>
-        <p:txBody>
-          <a:bodyPr spcFirstLastPara="1" wrap="square" lIns="91425" tIns="45700" rIns="91425" bIns="45700" anchor="t" anchorCtr="0">
-            <a:spAutoFit/>
-          </a:bodyPr>
-          <a:lstStyle/>
-          <a:p>
-            <a:pPr marL="0" marR="0" lvl="0" indent="0" algn="ctr" rtl="0">
-              <a:lnSpc>
-                <a:spcPct val="100000"/>
-              </a:lnSpc>
-              <a:spcBef>
-                <a:spcPts val="0"/>
-              </a:spcBef>
-              <a:spcAft>
-                <a:spcPts val="0"/>
-              </a:spcAft>
-              <a:buNone/>
-            </a:pPr>
-            <a:r>
-              <a:rPr lang="es-CO" sz="6000" b="1" dirty="0" err="1">
-                <a:solidFill>
-                  <a:schemeClr val="lt1"/>
-                </a:solidFill>
-                <a:latin typeface="Work Sans"/>
-                <a:ea typeface="Work Sans"/>
-                <a:cs typeface="Work Sans"/>
-                <a:sym typeface="Work Sans"/>
-              </a:rPr>
-              <a:t>React</a:t>
-            </a:r>
-            <a:endParaRPr sz="7200" b="1" i="0" u="none" strike="noStrike" cap="none" dirty="0">
-              <a:solidFill>
-                <a:schemeClr val="lt1"/>
-              </a:solidFill>
-              <a:latin typeface="Work Sans"/>
-              <a:ea typeface="Work Sans"/>
-              <a:cs typeface="Work Sans"/>
-              <a:sym typeface="Work Sans"/>
-            </a:endParaRPr>
-          </a:p>
-        </p:txBody>
-      </p:sp>
-      <p:cxnSp>
-        <p:nvCxnSpPr>
-          <p:cNvPr id="182" name="Google Shape;182;p34"/>
-          <p:cNvCxnSpPr/>
-          <p:nvPr/>
-        </p:nvCxnSpPr>
-        <p:spPr>
-          <a:xfrm>
-            <a:off x="5013631" y="3555133"/>
-            <a:ext cx="2247544" cy="0"/>
-          </a:xfrm>
-          <a:prstGeom prst="straightConnector1">
-            <a:avLst/>
-          </a:prstGeom>
-          <a:noFill/>
-          <a:ln w="12700" cap="flat" cmpd="sng">
-            <a:solidFill>
-              <a:schemeClr val="lt1"/>
-            </a:solidFill>
-            <a:prstDash val="solid"/>
-            <a:miter lim="8000"/>
-            <a:headEnd type="none" w="sm" len="sm"/>
-            <a:tailEnd type="none" w="sm" len="sm"/>
-          </a:ln>
-        </p:spPr>
-      </p:cxnSp>
-    </p:spTree>
   </p:cSld>
   <p:clrMapOvr>
     <a:masterClrMapping/>

</xml_diff>